<commit_message>
Fill slide placeholders (deliverables → examples/ templates, examples, resources)
Remaining 2 (mini-project examples domain, presentation logistics) pending user input.

Co-Authored-By: Claude Opus 4.8 <noreply@anthropic.com>
</commit_message>
<xml_diff>
--- a/slides/day2.pptx
+++ b/slides/day2.pptx
@@ -19823,7 +19823,7 @@
               </a:rPr>
               <a:t>Python + Claude Code 실행·로그인 완료
 문제 시 진단: claude doctor
-(스크린샷 placeholder)</a:t>
+(설치 완료 화면 캡처 삽입)</a:t>
             </a:r>
           </a:p>
         </p:txBody>
@@ -29247,7 +29247,7 @@
                 <a:cs typeface="NanumGothic"/>
               </a:rPr>
               <a:t>설정 완료 + 플러그인 설치된 작업 환경
-(설정·커맨드 예시 placeholder)</a:t>
+예시: examples/claude-setup (settings.json · CLAUDE.md)</a:t>
             </a:r>
           </a:p>
         </p:txBody>

</xml_diff>

<commit_message>
Remove remaining placeholders: 일반 mini-project examples, 4-team 발표, lab label
- Day 3 오전 examples: 가계부·일정·자료검색 (domain-neutral)
- Day 5 발표: 4팀 · 팀당 10분+Q&A 3분 (slides + timetable)
- slide_lab label '실습 단계 (placeholder)' → '실습 단계'
- drop unused PH/P defs; decks now placeholder-free

Co-Authored-By: Claude Opus 4.8 <noreply@anthropic.com>
</commit_message>
<xml_diff>
--- a/slides/day2.pptx
+++ b/slides/day2.pptx
@@ -19131,7 +19131,7 @@
                 <a:ea typeface="NanumGothic"/>
                 <a:cs typeface="NanumGothic"/>
               </a:rPr>
-              <a:t>실습 단계 (placeholder)</a:t>
+              <a:t>실습 단계</a:t>
             </a:r>
           </a:p>
         </p:txBody>
@@ -28556,7 +28556,7 @@
                 <a:ea typeface="NanumGothic"/>
                 <a:cs typeface="NanumGothic"/>
               </a:rPr>
-              <a:t>실습 단계 (placeholder)</a:t>
+              <a:t>실습 단계</a:t>
             </a:r>
           </a:p>
         </p:txBody>

</xml_diff>